<commit_message>
Document project impact and value in the Congolese context
- IMPACT.md: standalone impact brief (why it matters in DRC, value vs GFW/RADD,
  concrete beneficiaries, REDD+/Mai-Ndombe carbon finance, honest limits)
- memoir: new Chapter 5 'Impact et plus-value dans le contexte congolais'
- soutenance deck: 2 new slides (value in DRC context + impact by stakeholder)
- README links IMPACT.md; memoir/slides regenerated

Co-Authored-By: Claude Opus 4.8 <noreply@anthropic.com>
Claude-Session: https://claude.ai/code/session_012VEQmNdfkHMt6fhJx4FZvT
</commit_message>
<xml_diff>
--- a/docs/soutenance_deforestwatch.pptx
+++ b/docs/soutenance_deforestwatch.pptx
@@ -21,6 +21,8 @@
     <p:sldId id="269" r:id="rId20"/>
     <p:sldId id="270" r:id="rId21"/>
     <p:sldId id="271" r:id="rId22"/>
+    <p:sldId id="272" r:id="rId23"/>
+    <p:sldId id="273" r:id="rId24"/>
   </p:sldIdLst>
   <p:sldSz cx="9144000" cy="6858000" type="screen4x3"/>
   <p:notesSz cx="6858000" cy="9144000"/>
@@ -3811,7 +3813,7 @@
                   <a:srgbClr val="10B981"/>
                 </a:solidFill>
               </a:rPr>
-              <a:t>Limites</a:t>
+              <a:t>Plus-value dans le contexte congolais</a:t>
             </a:r>
           </a:p>
         </p:txBody>
@@ -3849,37 +3851,52 @@
                   <a:srgbClr val="F1F5F9"/>
                 </a:solidFill>
               </a:rPr>
-              <a:t>•  Couverture nuageuse équatoriale persistante.</a:t>
-            </a:r>
-          </a:p>
-          <a:p>
-            <a:pPr>
-              <a:spcAft>
-                <a:spcPts val="800"/>
-              </a:spcAft>
-            </a:pPr>
-            <a:r>
-              <a:rPr sz="1800">
-                <a:solidFill>
-                  <a:srgbClr val="F1F5F9"/>
-                </a:solidFill>
-              </a:rPr>
-              <a:t>•  Besoin de données de vérité terrain de qualité.</a:t>
-            </a:r>
-          </a:p>
-          <a:p>
-            <a:pPr>
-              <a:spcAft>
-                <a:spcPts val="800"/>
-              </a:spcAft>
-            </a:pPr>
-            <a:r>
-              <a:rPr sz="1800">
-                <a:solidFill>
-                  <a:srgbClr val="F1F5F9"/>
-                </a:solidFill>
-              </a:rPr>
-              <a:t>•  Résultats de démonstration à valider sur images réelles.</a:t>
+              <a:t>•  RDC : ~60 % de la forêt du Bassin du Congo ; déforestation diffuse (brûlis, charbon de bois) mal captée par les outils globaux.</a:t>
+            </a:r>
+          </a:p>
+          <a:p>
+            <a:pPr>
+              <a:spcAft>
+                <a:spcPts val="800"/>
+              </a:spcAft>
+            </a:pPr>
+            <a:r>
+              <a:rPr sz="1800">
+                <a:solidFill>
+                  <a:srgbClr val="F1F5F9"/>
+                </a:solidFill>
+              </a:rPr>
+              <a:t>•  Mai-Ndombe : province pilote REDD+ -&gt; réduire la déforestation a une valeur financière directe (paiements aux résultats).</a:t>
+            </a:r>
+          </a:p>
+          <a:p>
+            <a:pPr>
+              <a:spcAft>
+                <a:spcPts val="800"/>
+              </a:spcAft>
+            </a:pPr>
+            <a:r>
+              <a:rPr sz="1800">
+                <a:solidFill>
+                  <a:srgbClr val="F1F5F9"/>
+                </a:solidFill>
+              </a:rPr>
+              <a:t>•  D'un outil de CONSTAT à un outil d'ACTION : prédictif, en français, avec signalement citoyen et impact carbone.</a:t>
+            </a:r>
+          </a:p>
+          <a:p>
+            <a:pPr>
+              <a:spcAft>
+                <a:spcPts val="800"/>
+              </a:spcAft>
+            </a:pPr>
+            <a:r>
+              <a:rPr sz="1800">
+                <a:solidFill>
+                  <a:srgbClr val="F1F5F9"/>
+                </a:solidFill>
+              </a:rPr>
+              <a:t>•  Souveraineté des données : un outil conçu et maîtrisé localement.</a:t>
             </a:r>
           </a:p>
         </p:txBody>
@@ -3939,7 +3956,7 @@
                   <a:srgbClr val="10B981"/>
                 </a:solidFill>
               </a:rPr>
-              <a:t>Perspectives</a:t>
+              <a:t>Impact concret, par acteur</a:t>
             </a:r>
           </a:p>
         </p:txBody>
@@ -3977,52 +3994,82 @@
                   <a:srgbClr val="F1F5F9"/>
                 </a:solidFill>
               </a:rPr>
-              <a:t>•  Imagerie radar Sentinel-1 (insensible aux nuages).</a:t>
-            </a:r>
-          </a:p>
-          <a:p>
-            <a:pPr>
-              <a:spcAft>
-                <a:spcPts val="800"/>
-              </a:spcAft>
-            </a:pPr>
-            <a:r>
-              <a:rPr sz="1800">
-                <a:solidFill>
-                  <a:srgbClr val="F1F5F9"/>
-                </a:solidFill>
-              </a:rPr>
-              <a:t>•  Modèles spatio-temporels (ConvLSTM, transformers).</a:t>
-            </a:r>
-          </a:p>
-          <a:p>
-            <a:pPr>
-              <a:spcAft>
-                <a:spcPts val="800"/>
-              </a:spcAft>
-            </a:pPr>
-            <a:r>
-              <a:rPr sz="1800">
-                <a:solidFill>
-                  <a:srgbClr val="F1F5F9"/>
-                </a:solidFill>
-              </a:rPr>
-              <a:t>•  Alertes en temps quasi réel pour les gestionnaires forestiers.</a:t>
-            </a:r>
-          </a:p>
-          <a:p>
-            <a:pPr>
-              <a:spcAft>
-                <a:spcPts val="800"/>
-              </a:spcAft>
-            </a:pPr>
-            <a:r>
-              <a:rPr sz="1800">
-                <a:solidFill>
-                  <a:srgbClr val="F1F5F9"/>
-                </a:solidFill>
-              </a:rPr>
-              <a:t>•  Extension à d'autres provinces de la forêt équatoriale.</a:t>
+              <a:t>•  Ministère / DIAF : brique d'un système national de surveillance (MRV).</a:t>
+            </a:r>
+          </a:p>
+          <a:p>
+            <a:pPr>
+              <a:spcAft>
+                <a:spcPts val="800"/>
+              </a:spcAft>
+            </a:pPr>
+            <a:r>
+              <a:rPr sz="1800">
+                <a:solidFill>
+                  <a:srgbClr val="F1F5F9"/>
+                </a:solidFill>
+              </a:rPr>
+              <a:t>•  Gardes forestiers / ICCN : alertes géolocalisées + radar (sous les nuages).</a:t>
+            </a:r>
+          </a:p>
+          <a:p>
+            <a:pPr>
+              <a:spcAft>
+                <a:spcPts val="800"/>
+              </a:spcAft>
+            </a:pPr>
+            <a:r>
+              <a:rPr sz="1800">
+                <a:solidFill>
+                  <a:srgbClr val="F1F5F9"/>
+                </a:solidFill>
+              </a:rPr>
+              <a:t>•  Province du Mai-Ndombe : ciblage des secteurs prioritaires.</a:t>
+            </a:r>
+          </a:p>
+          <a:p>
+            <a:pPr>
+              <a:spcAft>
+                <a:spcPts val="800"/>
+              </a:spcAft>
+            </a:pPr>
+            <a:r>
+              <a:rPr sz="1800">
+                <a:solidFill>
+                  <a:srgbClr val="F1F5F9"/>
+                </a:solidFill>
+              </a:rPr>
+              <a:t>•  Communautés locales : signalement participatif.</a:t>
+            </a:r>
+          </a:p>
+          <a:p>
+            <a:pPr>
+              <a:spcAft>
+                <a:spcPts val="800"/>
+              </a:spcAft>
+            </a:pPr>
+            <a:r>
+              <a:rPr sz="1800">
+                <a:solidFill>
+                  <a:srgbClr val="F1F5F9"/>
+                </a:solidFill>
+              </a:rPr>
+              <a:t>•  ONG &amp; projets carbone : quantification pour les crédits (REDD+).</a:t>
+            </a:r>
+          </a:p>
+          <a:p>
+            <a:pPr>
+              <a:spcAft>
+                <a:spcPts val="800"/>
+              </a:spcAft>
+            </a:pPr>
+            <a:r>
+              <a:rPr sz="1800">
+                <a:solidFill>
+                  <a:srgbClr val="F1F5F9"/>
+                </a:solidFill>
+              </a:rPr>
+              <a:t>•  Bailleurs (CAFI, Banque mondiale) : transparence et paiements aux résultats.</a:t>
             </a:r>
           </a:p>
         </p:txBody>
@@ -4036,6 +4083,277 @@
 </file>
 
 <file path=ppt/slides/slide16.xml><?xml version="1.0" encoding="utf-8"?>
+<p:sld xmlns:a="http://schemas.openxmlformats.org/drawingml/2006/main" xmlns:p="http://schemas.openxmlformats.org/presentationml/2006/main" xmlns:r="http://schemas.openxmlformats.org/officeDocument/2006/relationships">
+  <p:cSld>
+    <p:bg>
+      <p:bgPr>
+        <a:solidFill>
+          <a:srgbClr val="0A0F1C"/>
+        </a:solidFill>
+        <a:effectLst/>
+      </p:bgPr>
+    </p:bg>
+    <p:spTree>
+      <p:nvGrpSpPr>
+        <p:cNvPr id="1" name=""/>
+        <p:cNvGrpSpPr/>
+        <p:nvPr/>
+      </p:nvGrpSpPr>
+      <p:grpSpPr/>
+      <p:sp>
+        <p:nvSpPr>
+          <p:cNvPr id="2" name="TextBox 1"/>
+          <p:cNvSpPr txBox="1"/>
+          <p:nvPr/>
+        </p:nvSpPr>
+        <p:spPr>
+          <a:xfrm>
+            <a:off x="822960" y="502920"/>
+            <a:ext cx="7498079" cy="914400"/>
+          </a:xfrm>
+          <a:prstGeom prst="rect">
+            <a:avLst/>
+          </a:prstGeom>
+          <a:noFill/>
+        </p:spPr>
+        <p:txBody>
+          <a:bodyPr wrap="square">
+            <a:spAutoFit/>
+          </a:bodyPr>
+          <a:lstStyle/>
+          <a:p>
+            <a:pPr algn="l"/>
+            <a:r>
+              <a:rPr sz="3000" b="1">
+                <a:solidFill>
+                  <a:srgbClr val="10B981"/>
+                </a:solidFill>
+              </a:rPr>
+              <a:t>Limites</a:t>
+            </a:r>
+          </a:p>
+        </p:txBody>
+      </p:sp>
+      <p:sp>
+        <p:nvSpPr>
+          <p:cNvPr id="3" name="TextBox 2"/>
+          <p:cNvSpPr txBox="1"/>
+          <p:nvPr/>
+        </p:nvSpPr>
+        <p:spPr>
+          <a:xfrm>
+            <a:off x="822960" y="1645920"/>
+            <a:ext cx="7498079" cy="4572000"/>
+          </a:xfrm>
+          <a:prstGeom prst="rect">
+            <a:avLst/>
+          </a:prstGeom>
+          <a:noFill/>
+        </p:spPr>
+        <p:txBody>
+          <a:bodyPr wrap="square">
+            <a:spAutoFit/>
+          </a:bodyPr>
+          <a:lstStyle/>
+          <a:p>
+            <a:pPr>
+              <a:spcAft>
+                <a:spcPts val="800"/>
+              </a:spcAft>
+            </a:pPr>
+            <a:r>
+              <a:rPr sz="1800">
+                <a:solidFill>
+                  <a:srgbClr val="F1F5F9"/>
+                </a:solidFill>
+              </a:rPr>
+              <a:t>•  Couverture nuageuse équatoriale persistante.</a:t>
+            </a:r>
+          </a:p>
+          <a:p>
+            <a:pPr>
+              <a:spcAft>
+                <a:spcPts val="800"/>
+              </a:spcAft>
+            </a:pPr>
+            <a:r>
+              <a:rPr sz="1800">
+                <a:solidFill>
+                  <a:srgbClr val="F1F5F9"/>
+                </a:solidFill>
+              </a:rPr>
+              <a:t>•  Besoin de données de vérité terrain de qualité.</a:t>
+            </a:r>
+          </a:p>
+          <a:p>
+            <a:pPr>
+              <a:spcAft>
+                <a:spcPts val="800"/>
+              </a:spcAft>
+            </a:pPr>
+            <a:r>
+              <a:rPr sz="1800">
+                <a:solidFill>
+                  <a:srgbClr val="F1F5F9"/>
+                </a:solidFill>
+              </a:rPr>
+              <a:t>•  Résultats de démonstration à valider sur images réelles.</a:t>
+            </a:r>
+          </a:p>
+        </p:txBody>
+      </p:sp>
+    </p:spTree>
+  </p:cSld>
+  <p:clrMapOvr>
+    <a:masterClrMapping/>
+  </p:clrMapOvr>
+</p:sld>
+</file>
+
+<file path=ppt/slides/slide17.xml><?xml version="1.0" encoding="utf-8"?>
+<p:sld xmlns:a="http://schemas.openxmlformats.org/drawingml/2006/main" xmlns:p="http://schemas.openxmlformats.org/presentationml/2006/main" xmlns:r="http://schemas.openxmlformats.org/officeDocument/2006/relationships">
+  <p:cSld>
+    <p:bg>
+      <p:bgPr>
+        <a:solidFill>
+          <a:srgbClr val="0A0F1C"/>
+        </a:solidFill>
+        <a:effectLst/>
+      </p:bgPr>
+    </p:bg>
+    <p:spTree>
+      <p:nvGrpSpPr>
+        <p:cNvPr id="1" name=""/>
+        <p:cNvGrpSpPr/>
+        <p:nvPr/>
+      </p:nvGrpSpPr>
+      <p:grpSpPr/>
+      <p:sp>
+        <p:nvSpPr>
+          <p:cNvPr id="2" name="TextBox 1"/>
+          <p:cNvSpPr txBox="1"/>
+          <p:nvPr/>
+        </p:nvSpPr>
+        <p:spPr>
+          <a:xfrm>
+            <a:off x="822960" y="502920"/>
+            <a:ext cx="7498079" cy="914400"/>
+          </a:xfrm>
+          <a:prstGeom prst="rect">
+            <a:avLst/>
+          </a:prstGeom>
+          <a:noFill/>
+        </p:spPr>
+        <p:txBody>
+          <a:bodyPr wrap="square">
+            <a:spAutoFit/>
+          </a:bodyPr>
+          <a:lstStyle/>
+          <a:p>
+            <a:pPr algn="l"/>
+            <a:r>
+              <a:rPr sz="3000" b="1">
+                <a:solidFill>
+                  <a:srgbClr val="10B981"/>
+                </a:solidFill>
+              </a:rPr>
+              <a:t>Perspectives</a:t>
+            </a:r>
+          </a:p>
+        </p:txBody>
+      </p:sp>
+      <p:sp>
+        <p:nvSpPr>
+          <p:cNvPr id="3" name="TextBox 2"/>
+          <p:cNvSpPr txBox="1"/>
+          <p:nvPr/>
+        </p:nvSpPr>
+        <p:spPr>
+          <a:xfrm>
+            <a:off x="822960" y="1645920"/>
+            <a:ext cx="7498079" cy="4572000"/>
+          </a:xfrm>
+          <a:prstGeom prst="rect">
+            <a:avLst/>
+          </a:prstGeom>
+          <a:noFill/>
+        </p:spPr>
+        <p:txBody>
+          <a:bodyPr wrap="square">
+            <a:spAutoFit/>
+          </a:bodyPr>
+          <a:lstStyle/>
+          <a:p>
+            <a:pPr>
+              <a:spcAft>
+                <a:spcPts val="800"/>
+              </a:spcAft>
+            </a:pPr>
+            <a:r>
+              <a:rPr sz="1800">
+                <a:solidFill>
+                  <a:srgbClr val="F1F5F9"/>
+                </a:solidFill>
+              </a:rPr>
+              <a:t>•  Imagerie radar Sentinel-1 (insensible aux nuages).</a:t>
+            </a:r>
+          </a:p>
+          <a:p>
+            <a:pPr>
+              <a:spcAft>
+                <a:spcPts val="800"/>
+              </a:spcAft>
+            </a:pPr>
+            <a:r>
+              <a:rPr sz="1800">
+                <a:solidFill>
+                  <a:srgbClr val="F1F5F9"/>
+                </a:solidFill>
+              </a:rPr>
+              <a:t>•  Modèles spatio-temporels (ConvLSTM, transformers).</a:t>
+            </a:r>
+          </a:p>
+          <a:p>
+            <a:pPr>
+              <a:spcAft>
+                <a:spcPts val="800"/>
+              </a:spcAft>
+            </a:pPr>
+            <a:r>
+              <a:rPr sz="1800">
+                <a:solidFill>
+                  <a:srgbClr val="F1F5F9"/>
+                </a:solidFill>
+              </a:rPr>
+              <a:t>•  Alertes en temps quasi réel pour les gestionnaires forestiers.</a:t>
+            </a:r>
+          </a:p>
+          <a:p>
+            <a:pPr>
+              <a:spcAft>
+                <a:spcPts val="800"/>
+              </a:spcAft>
+            </a:pPr>
+            <a:r>
+              <a:rPr sz="1800">
+                <a:solidFill>
+                  <a:srgbClr val="F1F5F9"/>
+                </a:solidFill>
+              </a:rPr>
+              <a:t>•  Extension à d'autres provinces de la forêt équatoriale.</a:t>
+            </a:r>
+          </a:p>
+        </p:txBody>
+      </p:sp>
+    </p:spTree>
+  </p:cSld>
+  <p:clrMapOvr>
+    <a:masterClrMapping/>
+  </p:clrMapOvr>
+</p:sld>
+</file>
+
+<file path=ppt/slides/slide18.xml><?xml version="1.0" encoding="utf-8"?>
 <p:sld xmlns:a="http://schemas.openxmlformats.org/drawingml/2006/main" xmlns:p="http://schemas.openxmlformats.org/presentationml/2006/main" xmlns:r="http://schemas.openxmlformats.org/officeDocument/2006/relationships">
   <p:cSld>
     <p:bg>

</xml_diff>